<commit_message>
Bentley guide and lab deck: sixteen iTwin Capture Modeler screenshots, labels verified in the app
Screenshots captured by driving iTwin Capture Modeler 2024 Update 1 on a
migrated copy of the instructor's Utah Lake project: project tree, Photos
tab, block 3D view, AT wizard (three pages), AT dashboard, quality report,
sparse cloud, reconstruction Spatial Framework and Processing Settings,
production wizard (three pages) and production overview. Placed through
software/bentley_itwin.md with captions crediting Bentley, as six slides
in the lab deck, and one on the Week 7 overview slide.

Labels corrected to what the app shows: Orthophoto/DSM, Submit Production,
Surveys tab, Resolution, Adjust poses when photos carry GPS. Five labels
still carry a verify comment for a TA.

Co-Authored-By: Claude Fable 5.1 <noreply@anthropic.com>
</commit_message>
<xml_diff>
--- a/docs/slides/bentley_itwin.pptx
+++ b/docs/slides/bentley_itwin.pptx
@@ -19,9 +19,15 @@
     <p:sldId id="267" r:id="rId13"/>
     <p:sldId id="268" r:id="rId14"/>
     <p:sldId id="269" r:id="rId15"/>
+    <p:sldId id="270" r:id="rId16"/>
+    <p:sldId id="271" r:id="rId17"/>
+    <p:sldId id="272" r:id="rId18"/>
+    <p:sldId id="273" r:id="rId19"/>
+    <p:sldId id="274" r:id="rId20"/>
+    <p:sldId id="275" r:id="rId21"/>
   </p:sldIdLst>
   <p:notesMasterIdLst>
-    <p:notesMasterId r:id="rId16"/>
+    <p:notesMasterId r:id="rId22"/>
   </p:notesMasterIdLst>
   <p:sldSz cx="12192000" cy="6858000"/>
   <p:notesSz cx="6858000" cy="12192000"/>
@@ -997,7 +1003,7 @@
 </p:notes>
 </file>
 
-<file path=ppt/notesSlides/notesSlide2.xml><?xml version="1.0" encoding="utf-8"?>
+<file path=ppt/notesSlides/notesSlide15.xml><?xml version="1.0" encoding="utf-8"?>
 <p:notes xmlns:a="http://schemas.openxmlformats.org/drawingml/2006/main" xmlns:r="http://schemas.openxmlformats.org/officeDocument/2006/relationships" xmlns:p="http://schemas.openxmlformats.org/presentationml/2006/main">
   <p:cSld>
     <p:spTree>
@@ -1066,7 +1072,535 @@
           <a:p>
             <a:fld id="{F7021451-1387-4CA6-816F-3879F97B5CBC}" type="slidenum">
               <a:rPr lang="en-US"/>
+              <a:t>15</a:t>
+            </a:fld>
+            <a:endParaRPr lang="en-US"/>
+          </a:p>
+        </p:txBody>
+      </p:sp>
+    </p:spTree>
+    <p:extLst>
+      <p:ext uri="{BB962C8B-B14F-4D97-AF65-F5344CB8AC3E}">
+        <p14:creationId xmlns:p14="http://schemas.microsoft.com/office/powerpoint/2010/main" val="1024086991"/>
+      </p:ext>
+    </p:extLst>
+  </p:cSld>
+  <p:clrMapOvr>
+    <a:masterClrMapping/>
+  </p:clrMapOvr>
+</p:notes>
+</file>
+
+<file path=ppt/notesSlides/notesSlide16.xml><?xml version="1.0" encoding="utf-8"?>
+<p:notes xmlns:a="http://schemas.openxmlformats.org/drawingml/2006/main" xmlns:r="http://schemas.openxmlformats.org/officeDocument/2006/relationships" xmlns:p="http://schemas.openxmlformats.org/presentationml/2006/main">
+  <p:cSld>
+    <p:spTree>
+      <p:nvGrpSpPr>
+        <p:cNvPr id="1" name=""/>
+        <p:cNvGrpSpPr/>
+        <p:nvPr/>
+      </p:nvGrpSpPr>
+      <p:grpSpPr>
+        <a:xfrm>
+          <a:off x="0" y="0"/>
+          <a:ext cx="0" cy="0"/>
+          <a:chOff x="0" y="0"/>
+          <a:chExt cx="0" cy="0"/>
+        </a:xfrm>
+      </p:grpSpPr>
+      <p:sp>
+        <p:nvSpPr>
+          <p:cNvPr id="2" name="Slide Image Placeholder 1"/>
+          <p:cNvSpPr>
+            <a:spLocks noGrp="1" noRot="1" noChangeAspect="1"/>
+          </p:cNvSpPr>
+          <p:nvPr>
+            <p:ph type="sldImg"/>
+          </p:nvPr>
+        </p:nvSpPr>
+        <p:spPr/>
+      </p:sp>
+      <p:sp>
+        <p:nvSpPr>
+          <p:cNvPr id="3" name="Notes Placeholder 2"/>
+          <p:cNvSpPr>
+            <a:spLocks noGrp="1"/>
+          </p:cNvSpPr>
+          <p:nvPr>
+            <p:ph type="body" idx="1"/>
+          </p:nvPr>
+        </p:nvSpPr>
+        <p:spPr/>
+        <p:txBody>
+          <a:bodyPr/>
+          <a:lstStyle/>
+          <a:p>
+            <a:r>
+              <a:rPr lang="en-US" dirty="0"/>
+              <a:t/>
+            </a:r>
+            <a:endParaRPr lang="en-US" dirty="0"/>
+          </a:p>
+        </p:txBody>
+      </p:sp>
+      <p:sp>
+        <p:nvSpPr>
+          <p:cNvPr id="4" name="Slide Number Placeholder 3"/>
+          <p:cNvSpPr>
+            <a:spLocks noGrp="1"/>
+          </p:cNvSpPr>
+          <p:nvPr>
+            <p:ph type="sldNum" sz="quarter" idx="10"/>
+          </p:nvPr>
+        </p:nvSpPr>
+        <p:spPr/>
+        <p:txBody>
+          <a:bodyPr/>
+          <a:lstStyle/>
+          <a:p>
+            <a:fld id="{F7021451-1387-4CA6-816F-3879F97B5CBC}" type="slidenum">
+              <a:rPr lang="en-US"/>
+              <a:t>16</a:t>
+            </a:fld>
+            <a:endParaRPr lang="en-US"/>
+          </a:p>
+        </p:txBody>
+      </p:sp>
+    </p:spTree>
+    <p:extLst>
+      <p:ext uri="{BB962C8B-B14F-4D97-AF65-F5344CB8AC3E}">
+        <p14:creationId xmlns:p14="http://schemas.microsoft.com/office/powerpoint/2010/main" val="1024086991"/>
+      </p:ext>
+    </p:extLst>
+  </p:cSld>
+  <p:clrMapOvr>
+    <a:masterClrMapping/>
+  </p:clrMapOvr>
+</p:notes>
+</file>
+
+<file path=ppt/notesSlides/notesSlide17.xml><?xml version="1.0" encoding="utf-8"?>
+<p:notes xmlns:a="http://schemas.openxmlformats.org/drawingml/2006/main" xmlns:r="http://schemas.openxmlformats.org/officeDocument/2006/relationships" xmlns:p="http://schemas.openxmlformats.org/presentationml/2006/main">
+  <p:cSld>
+    <p:spTree>
+      <p:nvGrpSpPr>
+        <p:cNvPr id="1" name=""/>
+        <p:cNvGrpSpPr/>
+        <p:nvPr/>
+      </p:nvGrpSpPr>
+      <p:grpSpPr>
+        <a:xfrm>
+          <a:off x="0" y="0"/>
+          <a:ext cx="0" cy="0"/>
+          <a:chOff x="0" y="0"/>
+          <a:chExt cx="0" cy="0"/>
+        </a:xfrm>
+      </p:grpSpPr>
+      <p:sp>
+        <p:nvSpPr>
+          <p:cNvPr id="2" name="Slide Image Placeholder 1"/>
+          <p:cNvSpPr>
+            <a:spLocks noGrp="1" noRot="1" noChangeAspect="1"/>
+          </p:cNvSpPr>
+          <p:nvPr>
+            <p:ph type="sldImg"/>
+          </p:nvPr>
+        </p:nvSpPr>
+        <p:spPr/>
+      </p:sp>
+      <p:sp>
+        <p:nvSpPr>
+          <p:cNvPr id="3" name="Notes Placeholder 2"/>
+          <p:cNvSpPr>
+            <a:spLocks noGrp="1"/>
+          </p:cNvSpPr>
+          <p:nvPr>
+            <p:ph type="body" idx="1"/>
+          </p:nvPr>
+        </p:nvSpPr>
+        <p:spPr/>
+        <p:txBody>
+          <a:bodyPr/>
+          <a:lstStyle/>
+          <a:p>
+            <a:r>
+              <a:rPr lang="en-US" dirty="0"/>
+              <a:t/>
+            </a:r>
+            <a:endParaRPr lang="en-US" dirty="0"/>
+          </a:p>
+        </p:txBody>
+      </p:sp>
+      <p:sp>
+        <p:nvSpPr>
+          <p:cNvPr id="4" name="Slide Number Placeholder 3"/>
+          <p:cNvSpPr>
+            <a:spLocks noGrp="1"/>
+          </p:cNvSpPr>
+          <p:nvPr>
+            <p:ph type="sldNum" sz="quarter" idx="10"/>
+          </p:nvPr>
+        </p:nvSpPr>
+        <p:spPr/>
+        <p:txBody>
+          <a:bodyPr/>
+          <a:lstStyle/>
+          <a:p>
+            <a:fld id="{F7021451-1387-4CA6-816F-3879F97B5CBC}" type="slidenum">
+              <a:rPr lang="en-US"/>
+              <a:t>17</a:t>
+            </a:fld>
+            <a:endParaRPr lang="en-US"/>
+          </a:p>
+        </p:txBody>
+      </p:sp>
+    </p:spTree>
+    <p:extLst>
+      <p:ext uri="{BB962C8B-B14F-4D97-AF65-F5344CB8AC3E}">
+        <p14:creationId xmlns:p14="http://schemas.microsoft.com/office/powerpoint/2010/main" val="1024086991"/>
+      </p:ext>
+    </p:extLst>
+  </p:cSld>
+  <p:clrMapOvr>
+    <a:masterClrMapping/>
+  </p:clrMapOvr>
+</p:notes>
+</file>
+
+<file path=ppt/notesSlides/notesSlide18.xml><?xml version="1.0" encoding="utf-8"?>
+<p:notes xmlns:a="http://schemas.openxmlformats.org/drawingml/2006/main" xmlns:r="http://schemas.openxmlformats.org/officeDocument/2006/relationships" xmlns:p="http://schemas.openxmlformats.org/presentationml/2006/main">
+  <p:cSld>
+    <p:spTree>
+      <p:nvGrpSpPr>
+        <p:cNvPr id="1" name=""/>
+        <p:cNvGrpSpPr/>
+        <p:nvPr/>
+      </p:nvGrpSpPr>
+      <p:grpSpPr>
+        <a:xfrm>
+          <a:off x="0" y="0"/>
+          <a:ext cx="0" cy="0"/>
+          <a:chOff x="0" y="0"/>
+          <a:chExt cx="0" cy="0"/>
+        </a:xfrm>
+      </p:grpSpPr>
+      <p:sp>
+        <p:nvSpPr>
+          <p:cNvPr id="2" name="Slide Image Placeholder 1"/>
+          <p:cNvSpPr>
+            <a:spLocks noGrp="1" noRot="1" noChangeAspect="1"/>
+          </p:cNvSpPr>
+          <p:nvPr>
+            <p:ph type="sldImg"/>
+          </p:nvPr>
+        </p:nvSpPr>
+        <p:spPr/>
+      </p:sp>
+      <p:sp>
+        <p:nvSpPr>
+          <p:cNvPr id="3" name="Notes Placeholder 2"/>
+          <p:cNvSpPr>
+            <a:spLocks noGrp="1"/>
+          </p:cNvSpPr>
+          <p:nvPr>
+            <p:ph type="body" idx="1"/>
+          </p:nvPr>
+        </p:nvSpPr>
+        <p:spPr/>
+        <p:txBody>
+          <a:bodyPr/>
+          <a:lstStyle/>
+          <a:p>
+            <a:r>
+              <a:rPr lang="en-US" dirty="0"/>
+              <a:t/>
+            </a:r>
+            <a:endParaRPr lang="en-US" dirty="0"/>
+          </a:p>
+        </p:txBody>
+      </p:sp>
+      <p:sp>
+        <p:nvSpPr>
+          <p:cNvPr id="4" name="Slide Number Placeholder 3"/>
+          <p:cNvSpPr>
+            <a:spLocks noGrp="1"/>
+          </p:cNvSpPr>
+          <p:nvPr>
+            <p:ph type="sldNum" sz="quarter" idx="10"/>
+          </p:nvPr>
+        </p:nvSpPr>
+        <p:spPr/>
+        <p:txBody>
+          <a:bodyPr/>
+          <a:lstStyle/>
+          <a:p>
+            <a:fld id="{F7021451-1387-4CA6-816F-3879F97B5CBC}" type="slidenum">
+              <a:rPr lang="en-US"/>
+              <a:t>18</a:t>
+            </a:fld>
+            <a:endParaRPr lang="en-US"/>
+          </a:p>
+        </p:txBody>
+      </p:sp>
+    </p:spTree>
+    <p:extLst>
+      <p:ext uri="{BB962C8B-B14F-4D97-AF65-F5344CB8AC3E}">
+        <p14:creationId xmlns:p14="http://schemas.microsoft.com/office/powerpoint/2010/main" val="1024086991"/>
+      </p:ext>
+    </p:extLst>
+  </p:cSld>
+  <p:clrMapOvr>
+    <a:masterClrMapping/>
+  </p:clrMapOvr>
+</p:notes>
+</file>
+
+<file path=ppt/notesSlides/notesSlide19.xml><?xml version="1.0" encoding="utf-8"?>
+<p:notes xmlns:a="http://schemas.openxmlformats.org/drawingml/2006/main" xmlns:r="http://schemas.openxmlformats.org/officeDocument/2006/relationships" xmlns:p="http://schemas.openxmlformats.org/presentationml/2006/main">
+  <p:cSld>
+    <p:spTree>
+      <p:nvGrpSpPr>
+        <p:cNvPr id="1" name=""/>
+        <p:cNvGrpSpPr/>
+        <p:nvPr/>
+      </p:nvGrpSpPr>
+      <p:grpSpPr>
+        <a:xfrm>
+          <a:off x="0" y="0"/>
+          <a:ext cx="0" cy="0"/>
+          <a:chOff x="0" y="0"/>
+          <a:chExt cx="0" cy="0"/>
+        </a:xfrm>
+      </p:grpSpPr>
+      <p:sp>
+        <p:nvSpPr>
+          <p:cNvPr id="2" name="Slide Image Placeholder 1"/>
+          <p:cNvSpPr>
+            <a:spLocks noGrp="1" noRot="1" noChangeAspect="1"/>
+          </p:cNvSpPr>
+          <p:nvPr>
+            <p:ph type="sldImg"/>
+          </p:nvPr>
+        </p:nvSpPr>
+        <p:spPr/>
+      </p:sp>
+      <p:sp>
+        <p:nvSpPr>
+          <p:cNvPr id="3" name="Notes Placeholder 2"/>
+          <p:cNvSpPr>
+            <a:spLocks noGrp="1"/>
+          </p:cNvSpPr>
+          <p:nvPr>
+            <p:ph type="body" idx="1"/>
+          </p:nvPr>
+        </p:nvSpPr>
+        <p:spPr/>
+        <p:txBody>
+          <a:bodyPr/>
+          <a:lstStyle/>
+          <a:p>
+            <a:r>
+              <a:rPr lang="en-US" dirty="0"/>
+              <a:t/>
+            </a:r>
+            <a:endParaRPr lang="en-US" dirty="0"/>
+          </a:p>
+        </p:txBody>
+      </p:sp>
+      <p:sp>
+        <p:nvSpPr>
+          <p:cNvPr id="4" name="Slide Number Placeholder 3"/>
+          <p:cNvSpPr>
+            <a:spLocks noGrp="1"/>
+          </p:cNvSpPr>
+          <p:nvPr>
+            <p:ph type="sldNum" sz="quarter" idx="10"/>
+          </p:nvPr>
+        </p:nvSpPr>
+        <p:spPr/>
+        <p:txBody>
+          <a:bodyPr/>
+          <a:lstStyle/>
+          <a:p>
+            <a:fld id="{F7021451-1387-4CA6-816F-3879F97B5CBC}" type="slidenum">
+              <a:rPr lang="en-US"/>
+              <a:t>19</a:t>
+            </a:fld>
+            <a:endParaRPr lang="en-US"/>
+          </a:p>
+        </p:txBody>
+      </p:sp>
+    </p:spTree>
+    <p:extLst>
+      <p:ext uri="{BB962C8B-B14F-4D97-AF65-F5344CB8AC3E}">
+        <p14:creationId xmlns:p14="http://schemas.microsoft.com/office/powerpoint/2010/main" val="1024086991"/>
+      </p:ext>
+    </p:extLst>
+  </p:cSld>
+  <p:clrMapOvr>
+    <a:masterClrMapping/>
+  </p:clrMapOvr>
+</p:notes>
+</file>
+
+<file path=ppt/notesSlides/notesSlide2.xml><?xml version="1.0" encoding="utf-8"?>
+<p:notes xmlns:a="http://schemas.openxmlformats.org/drawingml/2006/main" xmlns:r="http://schemas.openxmlformats.org/officeDocument/2006/relationships" xmlns:p="http://schemas.openxmlformats.org/presentationml/2006/main">
+  <p:cSld>
+    <p:spTree>
+      <p:nvGrpSpPr>
+        <p:cNvPr id="1" name=""/>
+        <p:cNvGrpSpPr/>
+        <p:nvPr/>
+      </p:nvGrpSpPr>
+      <p:grpSpPr>
+        <a:xfrm>
+          <a:off x="0" y="0"/>
+          <a:ext cx="0" cy="0"/>
+          <a:chOff x="0" y="0"/>
+          <a:chExt cx="0" cy="0"/>
+        </a:xfrm>
+      </p:grpSpPr>
+      <p:sp>
+        <p:nvSpPr>
+          <p:cNvPr id="2" name="Slide Image Placeholder 1"/>
+          <p:cNvSpPr>
+            <a:spLocks noGrp="1" noRot="1" noChangeAspect="1"/>
+          </p:cNvSpPr>
+          <p:nvPr>
+            <p:ph type="sldImg"/>
+          </p:nvPr>
+        </p:nvSpPr>
+        <p:spPr/>
+      </p:sp>
+      <p:sp>
+        <p:nvSpPr>
+          <p:cNvPr id="3" name="Notes Placeholder 2"/>
+          <p:cNvSpPr>
+            <a:spLocks noGrp="1"/>
+          </p:cNvSpPr>
+          <p:nvPr>
+            <p:ph type="body" idx="1"/>
+          </p:nvPr>
+        </p:nvSpPr>
+        <p:spPr/>
+        <p:txBody>
+          <a:bodyPr/>
+          <a:lstStyle/>
+          <a:p>
+            <a:r>
+              <a:rPr lang="en-US" dirty="0"/>
+              <a:t/>
+            </a:r>
+            <a:endParaRPr lang="en-US" dirty="0"/>
+          </a:p>
+        </p:txBody>
+      </p:sp>
+      <p:sp>
+        <p:nvSpPr>
+          <p:cNvPr id="4" name="Slide Number Placeholder 3"/>
+          <p:cNvSpPr>
+            <a:spLocks noGrp="1"/>
+          </p:cNvSpPr>
+          <p:nvPr>
+            <p:ph type="sldNum" sz="quarter" idx="10"/>
+          </p:nvPr>
+        </p:nvSpPr>
+        <p:spPr/>
+        <p:txBody>
+          <a:bodyPr/>
+          <a:lstStyle/>
+          <a:p>
+            <a:fld id="{F7021451-1387-4CA6-816F-3879F97B5CBC}" type="slidenum">
+              <a:rPr lang="en-US"/>
               <a:t>2</a:t>
+            </a:fld>
+            <a:endParaRPr lang="en-US"/>
+          </a:p>
+        </p:txBody>
+      </p:sp>
+    </p:spTree>
+    <p:extLst>
+      <p:ext uri="{BB962C8B-B14F-4D97-AF65-F5344CB8AC3E}">
+        <p14:creationId xmlns:p14="http://schemas.microsoft.com/office/powerpoint/2010/main" val="1024086991"/>
+      </p:ext>
+    </p:extLst>
+  </p:cSld>
+  <p:clrMapOvr>
+    <a:masterClrMapping/>
+  </p:clrMapOvr>
+</p:notes>
+</file>
+
+<file path=ppt/notesSlides/notesSlide20.xml><?xml version="1.0" encoding="utf-8"?>
+<p:notes xmlns:a="http://schemas.openxmlformats.org/drawingml/2006/main" xmlns:r="http://schemas.openxmlformats.org/officeDocument/2006/relationships" xmlns:p="http://schemas.openxmlformats.org/presentationml/2006/main">
+  <p:cSld>
+    <p:spTree>
+      <p:nvGrpSpPr>
+        <p:cNvPr id="1" name=""/>
+        <p:cNvGrpSpPr/>
+        <p:nvPr/>
+      </p:nvGrpSpPr>
+      <p:grpSpPr>
+        <a:xfrm>
+          <a:off x="0" y="0"/>
+          <a:ext cx="0" cy="0"/>
+          <a:chOff x="0" y="0"/>
+          <a:chExt cx="0" cy="0"/>
+        </a:xfrm>
+      </p:grpSpPr>
+      <p:sp>
+        <p:nvSpPr>
+          <p:cNvPr id="2" name="Slide Image Placeholder 1"/>
+          <p:cNvSpPr>
+            <a:spLocks noGrp="1" noRot="1" noChangeAspect="1"/>
+          </p:cNvSpPr>
+          <p:nvPr>
+            <p:ph type="sldImg"/>
+          </p:nvPr>
+        </p:nvSpPr>
+        <p:spPr/>
+      </p:sp>
+      <p:sp>
+        <p:nvSpPr>
+          <p:cNvPr id="3" name="Notes Placeholder 2"/>
+          <p:cNvSpPr>
+            <a:spLocks noGrp="1"/>
+          </p:cNvSpPr>
+          <p:nvPr>
+            <p:ph type="body" idx="1"/>
+          </p:nvPr>
+        </p:nvSpPr>
+        <p:spPr/>
+        <p:txBody>
+          <a:bodyPr/>
+          <a:lstStyle/>
+          <a:p>
+            <a:r>
+              <a:rPr lang="en-US" dirty="0"/>
+              <a:t/>
+            </a:r>
+            <a:endParaRPr lang="en-US" dirty="0"/>
+          </a:p>
+        </p:txBody>
+      </p:sp>
+      <p:sp>
+        <p:nvSpPr>
+          <p:cNvPr id="4" name="Slide Number Placeholder 3"/>
+          <p:cNvSpPr>
+            <a:spLocks noGrp="1"/>
+          </p:cNvSpPr>
+          <p:nvPr>
+            <p:ph type="sldNum" sz="quarter" idx="10"/>
+          </p:nvPr>
+        </p:nvSpPr>
+        <p:spPr/>
+        <p:txBody>
+          <a:bodyPr/>
+          <a:lstStyle/>
+          <a:p>
+            <a:fld id="{F7021451-1387-4CA6-816F-3879F97B5CBC}" type="slidenum">
+              <a:rPr lang="en-US"/>
+              <a:t>20</a:t>
             </a:fld>
             <a:endParaRPr lang="en-US"/>
           </a:p>
@@ -2242,9 +2776,243 @@
 </p:sld>
 </file>
 
+<file path=ppt/slides/slide15.xml><?xml version="1.0" encoding="utf-8"?>
+<p:sld xmlns:a="http://schemas.openxmlformats.org/drawingml/2006/main" xmlns:r="http://schemas.openxmlformats.org/officeDocument/2006/relationships" xmlns:p="http://schemas.openxmlformats.org/presentationml/2006/main">
+  <p:cSld name="Slide 15">
+    <p:bg>
+      <p:bgPr>
+        <a:blipFill dpi="0" rotWithShape="1">
+          <a:blip r:embed="rId1">
+            <a:lum/>
+          </a:blip>
+          <a:srcRect/>
+          <a:stretch>
+            <a:fillRect/>
+          </a:stretch>
+        </a:blipFill>
+        <a:effectLst/>
+      </p:bgPr>
+    </p:bg>
+    <p:spTree>
+      <p:nvGrpSpPr>
+        <p:cNvPr id="1" name=""/>
+        <p:cNvGrpSpPr/>
+        <p:nvPr/>
+      </p:nvGrpSpPr>
+      <p:grpSpPr>
+        <a:xfrm>
+          <a:off x="0" y="0"/>
+          <a:ext cx="0" cy="0"/>
+          <a:chOff x="0" y="0"/>
+          <a:chExt cx="0" cy="0"/>
+        </a:xfrm>
+      </p:grpSpPr>
+    </p:spTree>
+  </p:cSld>
+  <p:clrMapOvr>
+    <a:masterClrMapping/>
+  </p:clrMapOvr>
+</p:sld>
+</file>
+
+<file path=ppt/slides/slide16.xml><?xml version="1.0" encoding="utf-8"?>
+<p:sld xmlns:a="http://schemas.openxmlformats.org/drawingml/2006/main" xmlns:r="http://schemas.openxmlformats.org/officeDocument/2006/relationships" xmlns:p="http://schemas.openxmlformats.org/presentationml/2006/main">
+  <p:cSld name="Slide 16">
+    <p:bg>
+      <p:bgPr>
+        <a:blipFill dpi="0" rotWithShape="1">
+          <a:blip r:embed="rId1">
+            <a:lum/>
+          </a:blip>
+          <a:srcRect/>
+          <a:stretch>
+            <a:fillRect/>
+          </a:stretch>
+        </a:blipFill>
+        <a:effectLst/>
+      </p:bgPr>
+    </p:bg>
+    <p:spTree>
+      <p:nvGrpSpPr>
+        <p:cNvPr id="1" name=""/>
+        <p:cNvGrpSpPr/>
+        <p:nvPr/>
+      </p:nvGrpSpPr>
+      <p:grpSpPr>
+        <a:xfrm>
+          <a:off x="0" y="0"/>
+          <a:ext cx="0" cy="0"/>
+          <a:chOff x="0" y="0"/>
+          <a:chExt cx="0" cy="0"/>
+        </a:xfrm>
+      </p:grpSpPr>
+    </p:spTree>
+  </p:cSld>
+  <p:clrMapOvr>
+    <a:masterClrMapping/>
+  </p:clrMapOvr>
+</p:sld>
+</file>
+
+<file path=ppt/slides/slide17.xml><?xml version="1.0" encoding="utf-8"?>
+<p:sld xmlns:a="http://schemas.openxmlformats.org/drawingml/2006/main" xmlns:r="http://schemas.openxmlformats.org/officeDocument/2006/relationships" xmlns:p="http://schemas.openxmlformats.org/presentationml/2006/main">
+  <p:cSld name="Slide 17">
+    <p:bg>
+      <p:bgPr>
+        <a:blipFill dpi="0" rotWithShape="1">
+          <a:blip r:embed="rId1">
+            <a:lum/>
+          </a:blip>
+          <a:srcRect/>
+          <a:stretch>
+            <a:fillRect/>
+          </a:stretch>
+        </a:blipFill>
+        <a:effectLst/>
+      </p:bgPr>
+    </p:bg>
+    <p:spTree>
+      <p:nvGrpSpPr>
+        <p:cNvPr id="1" name=""/>
+        <p:cNvGrpSpPr/>
+        <p:nvPr/>
+      </p:nvGrpSpPr>
+      <p:grpSpPr>
+        <a:xfrm>
+          <a:off x="0" y="0"/>
+          <a:ext cx="0" cy="0"/>
+          <a:chOff x="0" y="0"/>
+          <a:chExt cx="0" cy="0"/>
+        </a:xfrm>
+      </p:grpSpPr>
+    </p:spTree>
+  </p:cSld>
+  <p:clrMapOvr>
+    <a:masterClrMapping/>
+  </p:clrMapOvr>
+</p:sld>
+</file>
+
+<file path=ppt/slides/slide18.xml><?xml version="1.0" encoding="utf-8"?>
+<p:sld xmlns:a="http://schemas.openxmlformats.org/drawingml/2006/main" xmlns:r="http://schemas.openxmlformats.org/officeDocument/2006/relationships" xmlns:p="http://schemas.openxmlformats.org/presentationml/2006/main">
+  <p:cSld name="Slide 18">
+    <p:bg>
+      <p:bgPr>
+        <a:blipFill dpi="0" rotWithShape="1">
+          <a:blip r:embed="rId1">
+            <a:lum/>
+          </a:blip>
+          <a:srcRect/>
+          <a:stretch>
+            <a:fillRect/>
+          </a:stretch>
+        </a:blipFill>
+        <a:effectLst/>
+      </p:bgPr>
+    </p:bg>
+    <p:spTree>
+      <p:nvGrpSpPr>
+        <p:cNvPr id="1" name=""/>
+        <p:cNvGrpSpPr/>
+        <p:nvPr/>
+      </p:nvGrpSpPr>
+      <p:grpSpPr>
+        <a:xfrm>
+          <a:off x="0" y="0"/>
+          <a:ext cx="0" cy="0"/>
+          <a:chOff x="0" y="0"/>
+          <a:chExt cx="0" cy="0"/>
+        </a:xfrm>
+      </p:grpSpPr>
+    </p:spTree>
+  </p:cSld>
+  <p:clrMapOvr>
+    <a:masterClrMapping/>
+  </p:clrMapOvr>
+</p:sld>
+</file>
+
+<file path=ppt/slides/slide19.xml><?xml version="1.0" encoding="utf-8"?>
+<p:sld xmlns:a="http://schemas.openxmlformats.org/drawingml/2006/main" xmlns:r="http://schemas.openxmlformats.org/officeDocument/2006/relationships" xmlns:p="http://schemas.openxmlformats.org/presentationml/2006/main">
+  <p:cSld name="Slide 19">
+    <p:bg>
+      <p:bgPr>
+        <a:blipFill dpi="0" rotWithShape="1">
+          <a:blip r:embed="rId1">
+            <a:lum/>
+          </a:blip>
+          <a:srcRect/>
+          <a:stretch>
+            <a:fillRect/>
+          </a:stretch>
+        </a:blipFill>
+        <a:effectLst/>
+      </p:bgPr>
+    </p:bg>
+    <p:spTree>
+      <p:nvGrpSpPr>
+        <p:cNvPr id="1" name=""/>
+        <p:cNvGrpSpPr/>
+        <p:nvPr/>
+      </p:nvGrpSpPr>
+      <p:grpSpPr>
+        <a:xfrm>
+          <a:off x="0" y="0"/>
+          <a:ext cx="0" cy="0"/>
+          <a:chOff x="0" y="0"/>
+          <a:chExt cx="0" cy="0"/>
+        </a:xfrm>
+      </p:grpSpPr>
+    </p:spTree>
+  </p:cSld>
+  <p:clrMapOvr>
+    <a:masterClrMapping/>
+  </p:clrMapOvr>
+</p:sld>
+</file>
+
 <file path=ppt/slides/slide2.xml><?xml version="1.0" encoding="utf-8"?>
 <p:sld xmlns:a="http://schemas.openxmlformats.org/drawingml/2006/main" xmlns:r="http://schemas.openxmlformats.org/officeDocument/2006/relationships" xmlns:p="http://schemas.openxmlformats.org/presentationml/2006/main">
   <p:cSld name="Slide 2">
+    <p:bg>
+      <p:bgPr>
+        <a:blipFill dpi="0" rotWithShape="1">
+          <a:blip r:embed="rId1">
+            <a:lum/>
+          </a:blip>
+          <a:srcRect/>
+          <a:stretch>
+            <a:fillRect/>
+          </a:stretch>
+        </a:blipFill>
+        <a:effectLst/>
+      </p:bgPr>
+    </p:bg>
+    <p:spTree>
+      <p:nvGrpSpPr>
+        <p:cNvPr id="1" name=""/>
+        <p:cNvGrpSpPr/>
+        <p:nvPr/>
+      </p:nvGrpSpPr>
+      <p:grpSpPr>
+        <a:xfrm>
+          <a:off x="0" y="0"/>
+          <a:ext cx="0" cy="0"/>
+          <a:chOff x="0" y="0"/>
+          <a:chExt cx="0" cy="0"/>
+        </a:xfrm>
+      </p:grpSpPr>
+    </p:spTree>
+  </p:cSld>
+  <p:clrMapOvr>
+    <a:masterClrMapping/>
+  </p:clrMapOvr>
+</p:sld>
+</file>
+
+<file path=ppt/slides/slide20.xml><?xml version="1.0" encoding="utf-8"?>
+<p:sld xmlns:a="http://schemas.openxmlformats.org/drawingml/2006/main" xmlns:r="http://schemas.openxmlformats.org/officeDocument/2006/relationships" xmlns:p="http://schemas.openxmlformats.org/presentationml/2006/main">
+  <p:cSld name="Slide 20">
     <p:bg>
       <p:bgPr>
         <a:blipFill dpi="0" rotWithShape="1">

</xml_diff>